<commit_message>
Polish deck copy; add Colab badges + presentation link to README
</commit_message>
<xml_diff>
--- a/Final-Project-STI-Kel5-Presentation.pptx
+++ b/Final-Project-STI-Kel5-Presentation.pptx
@@ -3267,7 +3267,7 @@
         <p:spPr>
           <a:xfrm>
             <a:off x="1783080" y="3950208"/>
-            <a:ext cx="8229600" cy="365760"/>
+            <a:ext cx="8778240" cy="365760"/>
           </a:xfrm>
           <a:prstGeom prst="rect">
             <a:avLst/>
@@ -3298,7 +3298,7 @@
                 </a:solidFill>
                 <a:latin typeface="Segoe UI Semibold"/>
               </a:rPr>
-              <a:t>Analisis &amp; Monitoring Data dengan Pendekatan CRISP-DM</a:t>
+              <a:t>Analisis Data &amp; Dashboard Pemantauan dengan Pendekatan CRISP-DM</a:t>
             </a:r>
           </a:p>
         </p:txBody>
@@ -3787,7 +3787,7 @@
                 </a:solidFill>
                 <a:latin typeface="Segoe UI Black"/>
               </a:rPr>
-              <a:t>BUSINESS QUESTIONS</a:t>
+              <a:t>PERTANYAAN BISNIS</a:t>
             </a:r>
           </a:p>
         </p:txBody>
@@ -3931,7 +3931,7 @@
                 </a:solidFill>
                 <a:latin typeface="Segoe UI"/>
               </a:rPr>
-              <a:t> ingin memahami kinerja penjualannya selama ~3,5 tahun (data agregat mingguan, anonim) untuk mendukung keputusan stok, promo, dan target.</a:t>
+              <a:t> ingin memahami kinerja penjualannya selama kurang lebih 3,5 tahun (data agregat mingguan dan anonim) sebagai dasar keputusan stok, promo, dan target penjualan.</a:t>
             </a:r>
           </a:p>
         </p:txBody>
@@ -4089,7 +4089,7 @@
                 </a:solidFill>
                 <a:latin typeface="Segoe UI"/>
               </a:rPr>
-              <a:t>Bagaimana tren revenue, transaksi, dan pelanggan dari waktu ke waktu?</a:t>
+              <a:t>Bagaimana arah tren revenue, transaksi, dan jumlah pelanggan dari waktu ke waktu?</a:t>
             </a:r>
           </a:p>
         </p:txBody>
@@ -4247,7 +4247,7 @@
                 </a:solidFill>
                 <a:latin typeface="Segoe UI"/>
               </a:rPr>
-              <a:t>Pertumbuhan ditarik oleh volume transaksi atau nilai per transaksi (AOV)?</a:t>
+              <a:t>Pertumbuhan lebih ditarik oleh volume transaksi atau nilai per transaksi (AOV)?</a:t>
             </a:r>
           </a:p>
         </p:txBody>
@@ -4405,7 +4405,7 @@
                 </a:solidFill>
                 <a:latin typeface="Segoe UI"/>
               </a:rPr>
-              <a:t>Adakah bulan ramai/sepi untuk perencanaan stok &amp; campaign?</a:t>
+              <a:t>Adakah bulan ramai dan sepi yang bisa dipakai merencanakan stok dan campaign?</a:t>
             </a:r>
           </a:p>
         </p:txBody>
@@ -4563,7 +4563,7 @@
                 </a:solidFill>
                 <a:latin typeface="Segoe UI"/>
               </a:rPr>
-              <a:t>Seberapa efektif strategi diskon terhadap revenue?</a:t>
+              <a:t>Seberapa besar pengaruh strategi diskon terhadap revenue?</a:t>
             </a:r>
           </a:p>
         </p:txBody>
@@ -5004,7 +5004,7 @@
                 </a:solidFill>
                 <a:latin typeface="Segoe UI"/>
               </a:rPr>
-              <a:t>Scorecard KPI: revenue, transaksi, AOV, rata-rata diskon.</a:t>
+              <a:t>Scorecard KPI: revenue, transaksi, AOV, dan rata-rata diskon.</a:t>
             </a:r>
           </a:p>
           <a:p>
@@ -5032,7 +5032,7 @@
                 </a:solidFill>
                 <a:latin typeface="Segoe UI"/>
               </a:rPr>
-              <a:t>Tren revenue mingguan + rata-rata 4 minggu (range slider, dropdown tahun).</a:t>
+              <a:t>Tren revenue mingguan beserta rata-rata 4 minggu (range slider dan dropdown tahun).</a:t>
             </a:r>
           </a:p>
           <a:p>
@@ -5060,7 +5060,7 @@
                 </a:solidFill>
                 <a:latin typeface="Segoe UI"/>
               </a:rPr>
-              <a:t>Revenue per tahun &amp; pola musiman per bulan.</a:t>
+              <a:t>Revenue per tahun dan pola musiman per bulan.</a:t>
             </a:r>
           </a:p>
           <a:p>
@@ -5088,7 +5088,7 @@
                 </a:solidFill>
                 <a:latin typeface="Segoe UI"/>
               </a:rPr>
-              <a:t>AOV per tahun &amp; scatter diskon vs revenue.</a:t>
+              <a:t>AOV per tahun dan scatter diskon terhadap revenue.</a:t>
             </a:r>
           </a:p>
         </p:txBody>
@@ -5142,7 +5142,7 @@
                 </a:solidFill>
                 <a:latin typeface="Segoe UI"/>
               </a:rPr>
-              <a:t>hover, zoom, filter tahun, langsung di notebook.</a:t>
+              <a:t>hover, zoom, dan filter per tahun, langsung di dalam notebook.</a:t>
             </a:r>
           </a:p>
         </p:txBody>
@@ -6329,7 +6329,7 @@
                 </a:solidFill>
                 <a:latin typeface="Segoe UI"/>
               </a:rPr>
-              <a:t>Revenue tahunan naik ~5× dalam dua tahun (2023 → 2025).</a:t>
+              <a:t>Revenue tahunan tumbuh sekitar 5 kali lipat dalam dua tahun (2023 → 2025).</a:t>
             </a:r>
           </a:p>
           <a:p>
@@ -6357,7 +6357,7 @@
                 </a:solidFill>
                 <a:latin typeface="Segoe UI"/>
               </a:rPr>
-              <a:t>Pendorong = nilai (AOV naik tajam), bukan sekadar jumlah transaksi.</a:t>
+              <a:t>Pendorong utamanya adalah kenaikan nilai per transaksi (AOV), bukan semata jumlah transaksi.</a:t>
             </a:r>
           </a:p>
           <a:p>
@@ -6385,7 +6385,7 @@
                 </a:solidFill>
                 <a:latin typeface="Segoe UI"/>
               </a:rPr>
-              <a:t>Diskon belum efektif: rata-rata ~36% namun korelasi diskon-revenue ~0 → indikasi over-discounting.</a:t>
+              <a:t>Diskon belum efektif: rata-rata mencapai ~36%, tetapi korelasinya terhadap revenue mendekati nol, mengindikasikan over-discounting.</a:t>
             </a:r>
           </a:p>
         </p:txBody>
@@ -6529,7 +6529,7 @@
                 </a:solidFill>
                 <a:latin typeface="Segoe UI"/>
               </a:rPr>
-              <a:t>Pertahankan momentum AOV via bundling/upsell (keranjang masih 1,3 item).</a:t>
+              <a:t>Jaga momentum AOV lewat bundling dan upsell, mengingat keranjang masih sekitar 1,3 item.</a:t>
             </a:r>
           </a:p>
           <a:p>
@@ -6557,7 +6557,7 @@
                 </a:solidFill>
                 <a:latin typeface="Segoe UI"/>
               </a:rPr>
-              <a:t>Evaluasi strategi diskon: uji kurangi diskon, ukur dampak ke revenue.</a:t>
+              <a:t>Evaluasi strategi diskon dengan menguji pengurangan diskon dan mengukur dampaknya terhadap revenue.</a:t>
             </a:r>
           </a:p>
           <a:p>
@@ -6585,7 +6585,7 @@
                 </a:solidFill>
                 <a:latin typeface="Segoe UI"/>
               </a:rPr>
-              <a:t>Manfaatkan puncak musiman (Jun–Jul, Jan) untuk stok &amp; promo.</a:t>
+              <a:t>Manfaatkan puncak musiman (Juni–Juli dan Januari) untuk perencanaan stok dan promo.</a:t>
             </a:r>
           </a:p>
           <a:p>
@@ -6613,7 +6613,7 @@
                 </a:solidFill>
                 <a:latin typeface="Segoe UI"/>
               </a:rPr>
-              <a:t>Dorong akuisisi/retensi pelanggan (jumlah pelanggan relatif stagnan).</a:t>
+              <a:t>Dorong akuisisi dan retensi pelanggan karena jumlahnya cenderung stagnan.</a:t>
             </a:r>
           </a:p>
         </p:txBody>
@@ -6930,7 +6930,7 @@
                 </a:solidFill>
                 <a:latin typeface="Segoe UI"/>
               </a:rPr>
-              <a:t>Pendekatan CRISP-DM berhasil mengubah dua dataset mentah menjadi artefak pemantauan yang menjawab pertanyaan bisnis nyata.</a:t>
+              <a:t>Pendekatan CRISP-DM berhasil mengubah dua dataset mentah menjadi dashboard pemantauan yang menjawab pertanyaan bisnis nyata.</a:t>
             </a:r>
           </a:p>
           <a:p>
@@ -6958,7 +6958,7 @@
                 </a:solidFill>
                 <a:latin typeface="Segoe UI"/>
               </a:rPr>
-              <a:t>Inventory CGS-1: aset siap (~94% aktif), namun gap data kalibrasi menjadi prioritas tindak lanjut keselamatan &amp; kepatuhan.</a:t>
+              <a:t>Inventory CGS-1: ketersediaan aset tergolong baik (~94% aktif), tetapi gap data kalibrasi perlu segera ditindaklanjuti demi keselamatan dan kepatuhan.</a:t>
             </a:r>
           </a:p>
           <a:p>
@@ -6986,7 +6986,7 @@
                 </a:solidFill>
                 <a:latin typeface="Segoe UI"/>
               </a:rPr>
-              <a:t>Penjualan ritel: pertumbuhan kuat (~5×) ditarik kenaikan AOV; strategi diskon perlu dievaluasi (indikasi over-discounting).</a:t>
+              <a:t>Penjualan ritel: pertumbuhan kuat (~5×) ditopang kenaikan AOV, sementara strategi diskon perlu dievaluasi karena terindikasi over-discounting.</a:t>
             </a:r>
           </a:p>
           <a:p>
@@ -7014,7 +7014,7 @@
                 </a:solidFill>
                 <a:latin typeface="Segoe UI"/>
               </a:rPr>
-              <a:t>Manajemen proyek via GitHub Projects menjaga pekerjaan kelompok transparan, terbagi, dan terlacak (12 selesai · 2 berjalan · 2 antre).</a:t>
+              <a:t>Manajemen proyek lewat GitHub Projects menjaga pekerjaan kelompok tetap transparan, terbagi rapi, dan terlacak (12 selesai, 2 berjalan, 2 antre).</a:t>
             </a:r>
           </a:p>
           <a:p>
@@ -7042,7 +7042,7 @@
                 </a:solidFill>
                 <a:latin typeface="Segoe UI"/>
               </a:rPr>
-              <a:t>Tindak lanjut terbuka: bersihkan outlier data penjualan dan finalisasi dashboard Looker Studio inventory.</a:t>
+              <a:t>Langkah berikutnya: membersihkan outlier pada data penjualan dan menuntaskan dashboard Looker Studio untuk inventory.</a:t>
             </a:r>
           </a:p>
         </p:txBody>
@@ -7696,7 +7696,7 @@
                 </a:solidFill>
                 <a:latin typeface="Segoe UI"/>
               </a:rPr>
-              <a:t>Konteks dua studi kasus dan business questions</a:t>
+              <a:t>Konteks dua studi kasus dan pertanyaan bisnis yang ingin dijawab</a:t>
             </a:r>
           </a:p>
         </p:txBody>
@@ -7854,7 +7854,7 @@
                 </a:solidFill>
                 <a:latin typeface="Segoe UI"/>
               </a:rPr>
-              <a:t>Kerangka kerja pengolahan data end-to-end</a:t>
+              <a:t>Kerangka kerja pengolahan data dari awal hingga akhir</a:t>
             </a:r>
           </a:p>
         </p:txBody>
@@ -8012,7 +8012,7 @@
                 </a:solidFill>
                 <a:latin typeface="Segoe UI"/>
               </a:rPr>
-              <a:t>Pelacakan pekerjaan via GitHub Projects (kanban)</a:t>
+              <a:t>Pelacakan pekerjaan kelompok lewat GitHub Projects</a:t>
             </a:r>
           </a:p>
         </p:txBody>
@@ -8170,7 +8170,7 @@
                 </a:solidFill>
                 <a:latin typeface="Segoe UI"/>
               </a:rPr>
-              <a:t>Monitoring kesiapan &amp; kalibrasi instrumen</a:t>
+              <a:t>Pemantauan kesiapan dan kalibrasi instrumen</a:t>
             </a:r>
           </a:p>
         </p:txBody>
@@ -8328,7 +8328,7 @@
                 </a:solidFill>
                 <a:latin typeface="Segoe UI"/>
               </a:rPr>
-              <a:t>Tren, pendorong revenue, musiman, diskon</a:t>
+              <a:t>Tren, pendorong revenue, musiman, dan diskon</a:t>
             </a:r>
           </a:p>
         </p:txBody>
@@ -8486,7 +8486,7 @@
                 </a:solidFill>
                 <a:latin typeface="Segoe UI"/>
               </a:rPr>
-              <a:t>Temuan utama dan tindak lanjut</a:t>
+              <a:t>Temuan utama dan langkah tindak lanjut</a:t>
             </a:r>
           </a:p>
         </p:txBody>
@@ -8806,7 +8806,7 @@
                 </a:solidFill>
                 <a:latin typeface="Segoe UI"/>
               </a:rPr>
-              <a:t>Tim mengangkat </a:t>
+              <a:t>Kelompok mengambil </a:t>
             </a:r>
             <a:r>
               <a:rPr sz="1400" b="1">
@@ -8815,7 +8815,7 @@
                 </a:solidFill>
                 <a:latin typeface="Segoe UI Semibold"/>
               </a:rPr>
-              <a:t>dua studi kasus pengolahan data nyata</a:t>
+              <a:t>dua studi kasus nyata</a:t>
             </a:r>
             <a:r>
               <a:rPr sz="1400" b="0">
@@ -8824,7 +8824,7 @@
                 </a:solidFill>
                 <a:latin typeface="Segoe UI"/>
               </a:rPr>
-              <a:t> dari lingkungan kerja anggota, lalu mengolahnya secara terstruktur (CRISP-DM) hingga menjadi dashboard pemantauan.</a:t>
+              <a:t> dari lingkungan kerja anggota, lalu mengolah datanya secara terstruktur mengikuti CRISP-DM hingga menghasilkan dashboard pemantauan.</a:t>
             </a:r>
           </a:p>
         </p:txBody>
@@ -9057,7 +9057,7 @@
                 </a:solidFill>
                 <a:latin typeface="Segoe UI"/>
               </a:rPr>
-              <a:t>Monitoring kesiapan instrumen lapangan (transmitter, valve, actuator) pada Custody Gas Station.</a:t>
+              <a:t>Memantau kesiapan instrumen lapangan (transmitter, valve, actuator) di Custody Gas Station (CGS-1).</a:t>
             </a:r>
           </a:p>
           <a:p>
@@ -9085,7 +9085,7 @@
                 </a:solidFill>
                 <a:latin typeface="Segoe UI"/>
               </a:rPr>
-              <a:t>Fokus: status aset, ketergantungan vendor, dan gap data kalibrasi (keselamatan &amp; kepatuhan).</a:t>
+              <a:t>Menyoroti status aset, ketergantungan vendor, dan kelengkapan data kalibrasi yang menyangkut keselamatan serta kepatuhan.</a:t>
             </a:r>
           </a:p>
           <a:p>
@@ -9113,7 +9113,7 @@
                 </a:solidFill>
                 <a:latin typeface="Segoe UI"/>
               </a:rPr>
-              <a:t>Output: dashboard Looker Studio.</a:t>
+              <a:t>Hasil akhir disajikan sebagai dashboard Looker Studio.</a:t>
             </a:r>
           </a:p>
         </p:txBody>
@@ -9346,7 +9346,7 @@
                 </a:solidFill>
                 <a:latin typeface="Segoe UI"/>
               </a:rPr>
-              <a:t>Data penjualan B2C agregat mingguan, 2022–2026 (~3,5 tahun).</a:t>
+              <a:t>Data penjualan B2C agregat mingguan sepanjang 2022–2026 (sekitar 3,5 tahun).</a:t>
             </a:r>
           </a:p>
           <a:p>
@@ -9374,7 +9374,7 @@
                 </a:solidFill>
                 <a:latin typeface="Segoe UI"/>
               </a:rPr>
-              <a:t>Fokus: tren &amp; pertumbuhan, pendorong revenue, pola musiman, efektivitas diskon.</a:t>
+              <a:t>Menelusuri tren pertumbuhan, pendorong revenue, pola musiman, dan efektivitas diskon.</a:t>
             </a:r>
           </a:p>
           <a:p>
@@ -9402,7 +9402,7 @@
                 </a:solidFill>
                 <a:latin typeface="Segoe UI"/>
               </a:rPr>
-              <a:t>Output: dashboard interaktif Plotly.</a:t>
+              <a:t>Hasil akhir disajikan sebagai dashboard interaktif Plotly.</a:t>
             </a:r>
           </a:p>
         </p:txBody>
@@ -9722,7 +9722,7 @@
                 </a:solidFill>
                 <a:latin typeface="Segoe UI"/>
               </a:rPr>
-              <a:t>Setiap studi kasus mengikuti enam fase CRISP-DM berurutan, dari pemahaman bisnis hingga deployment dashboard.</a:t>
+              <a:t>Kedua studi kasus dikerjakan melalui enam fase CRISP-DM secara berurutan, mulai dari pemahaman bisnis hingga penyajian dashboard.</a:t>
             </a:r>
           </a:p>
         </p:txBody>
@@ -9973,7 +9973,7 @@
                 </a:solidFill>
                 <a:latin typeface="Segoe UI"/>
               </a:rPr>
-              <a:t>Tujuan &amp; business questions</a:t>
+              <a:t>Tujuan &amp; pertanyaan bisnis</a:t>
             </a:r>
           </a:p>
         </p:txBody>
@@ -10268,7 +10268,7 @@
                 </a:solidFill>
                 <a:latin typeface="Segoe UI"/>
               </a:rPr>
-              <a:t>Load data, profil kualitas</a:t>
+              <a:t>Memuat data, menilai kualitas</a:t>
             </a:r>
           </a:p>
         </p:txBody>
@@ -10563,7 +10563,7 @@
                 </a:solidFill>
                 <a:latin typeface="Segoe UI"/>
               </a:rPr>
-              <a:t>Cleaning, kolom turunan</a:t>
+              <a:t>Pembersihan &amp; kolom turunan</a:t>
             </a:r>
           </a:p>
         </p:txBody>
@@ -11404,7 +11404,7 @@
                 </a:solidFill>
                 <a:latin typeface="Segoe UI"/>
               </a:rPr>
-              <a:t>Dashboard monitoring</a:t>
+              <a:t>Dashboard pemantauan</a:t>
             </a:r>
           </a:p>
         </p:txBody>
@@ -11449,7 +11449,7 @@
                 </a:solidFill>
                 <a:latin typeface="Segoe UI"/>
               </a:rPr>
-              <a:t>Pendekatan ini memastikan analisis selalu berangkat dari pertanyaan bisnis dan diakhiri dengan artefak yang dapat dipantau, bukan sekadar grafik lepas.</a:t>
+              <a:t>Dengan kerangka ini, analisis selalu berangkat dari pertanyaan bisnis yang jelas dan berakhir pada dashboard yang siap dipantau, bukan sekadar kumpulan grafik.</a:t>
             </a:r>
           </a:p>
         </p:txBody>
@@ -11738,7 +11738,7 @@
         <p:spPr>
           <a:xfrm>
             <a:off x="822960" y="1481328"/>
-            <a:ext cx="10607040" cy="731520"/>
+            <a:ext cx="10607040" cy="777240"/>
           </a:xfrm>
           <a:prstGeom prst="rect">
             <a:avLst/>
@@ -11769,7 +11769,7 @@
                 </a:solidFill>
                 <a:latin typeface="Segoe UI"/>
               </a:rPr>
-              <a:t>Pekerjaan kelompok dikelola pada </a:t>
+              <a:t>Seluruh pekerjaan kelompok dikelola lewat </a:t>
             </a:r>
             <a:r>
               <a:rPr sz="1400" b="1">
@@ -11787,7 +11787,7 @@
                 </a:solidFill>
                 <a:latin typeface="Segoe UI"/>
               </a:rPr>
-              <a:t>, dengan setiap fase CRISP-DM dari kedua studi kasus dipecah menjadi kartu tugas dan dilacak melalui kolom </a:t>
+              <a:t>. Setiap fase CRISP-DM dari kedua studi kasus dipecah menjadi kartu tugas, lalu dilacak perpindahannya dari </a:t>
             </a:r>
             <a:r>
               <a:rPr sz="1400" b="1">
@@ -11987,7 +11987,7 @@
                 </a:solidFill>
                 <a:latin typeface="Segoe UI"/>
               </a:rPr>
-              <a:t>Status tiap pekerjaan terlihat satu layar, tidak ada tugas yang "hilang".</a:t>
+              <a:t>Status setiap pekerjaan terlihat dalam satu layar, sehingga tidak ada tugas yang terlewat.</a:t>
             </a:r>
           </a:p>
         </p:txBody>
@@ -12169,7 +12169,7 @@
                 </a:solidFill>
                 <a:latin typeface="Segoe UI"/>
               </a:rPr>
-              <a:t>Pemecahan tugas yang jelas memudahkan pembagian kerja antar anggota.</a:t>
+              <a:t>Tugas yang terpecah jelas memudahkan pembagian kerja antaranggota.</a:t>
             </a:r>
           </a:p>
         </p:txBody>
@@ -12351,7 +12351,7 @@
                 </a:solidFill>
                 <a:latin typeface="Segoe UI"/>
               </a:rPr>
-              <a:t>Progres terukur (12 selesai, 2 berjalan, 2 antre) dan terhubung ke repositori kode.</a:t>
+              <a:t>Progres terukur (12 selesai, 2 berjalan, 2 antre) dan langsung terhubung ke repositori kode.</a:t>
             </a:r>
           </a:p>
         </p:txBody>
@@ -13553,7 +13553,7 @@
                 </a:solidFill>
                 <a:latin typeface="Segoe UI"/>
               </a:rPr>
-              <a:t>Kartu = fase CRISP-DM kedua studi kasus + setup, dokumentasi, dan pengumpulan.</a:t>
+              <a:t>Tiap kartu mewakili satu fase CRISP-DM dari kedua studi kasus, ditambah setup, dokumentasi, dan pengumpulan.</a:t>
             </a:r>
           </a:p>
         </p:txBody>
@@ -14186,7 +14186,7 @@
               </a:spcAft>
             </a:pPr>
             <a:r>
-              <a:rPr sz="1250" b="1">
+              <a:rPr sz="1200" b="1">
                 <a:solidFill>
                   <a:srgbClr val="123047"/>
                 </a:solidFill>
@@ -14277,13 +14277,13 @@
               </a:spcAft>
             </a:pPr>
             <a:r>
-              <a:rPr sz="1250" b="0">
+              <a:rPr sz="1200" b="0">
                 <a:solidFill>
                   <a:srgbClr val="1E2C33"/>
                 </a:solidFill>
                 <a:latin typeface="Segoe UI"/>
               </a:rPr>
-              <a:t>Definisi 3 business question</a:t>
+              <a:t>Menyusun 3 pertanyaan bisnis</a:t>
             </a:r>
           </a:p>
         </p:txBody>
@@ -14368,13 +14368,13 @@
               </a:spcAft>
             </a:pPr>
             <a:r>
-              <a:rPr sz="1250" b="0">
+              <a:rPr sz="1200" b="0">
                 <a:solidFill>
                   <a:srgbClr val="1E2C33"/>
                 </a:solidFill>
                 <a:latin typeface="Segoe UI"/>
               </a:rPr>
-              <a:t>Definisi 4 business question</a:t>
+              <a:t>Menyusun 4 pertanyaan bisnis</a:t>
             </a:r>
           </a:p>
         </p:txBody>
@@ -14459,7 +14459,7 @@
               </a:spcAft>
             </a:pPr>
             <a:r>
-              <a:rPr sz="1250" b="1">
+              <a:rPr sz="1200" b="1">
                 <a:solidFill>
                   <a:srgbClr val="123047"/>
                 </a:solidFill>
@@ -14550,13 +14550,13 @@
               </a:spcAft>
             </a:pPr>
             <a:r>
-              <a:rPr sz="1250" b="0">
+              <a:rPr sz="1200" b="0">
                 <a:solidFill>
                   <a:srgbClr val="1E2C33"/>
                 </a:solidFill>
                 <a:latin typeface="Segoe UI"/>
               </a:rPr>
-              <a:t>Load Excel, profil missing</a:t>
+              <a:t>Memuat Excel, memeriksa data hilang</a:t>
             </a:r>
           </a:p>
         </p:txBody>
@@ -14641,13 +14641,13 @@
               </a:spcAft>
             </a:pPr>
             <a:r>
-              <a:rPr sz="1250" b="0">
+              <a:rPr sz="1200" b="0">
                 <a:solidFill>
                   <a:srgbClr val="1E2C33"/>
                 </a:solidFill>
                 <a:latin typeface="Segoe UI"/>
               </a:rPr>
-              <a:t>Ingest data mingguan, kamus data</a:t>
+              <a:t>Memuat data mingguan &amp; kamus data</a:t>
             </a:r>
           </a:p>
         </p:txBody>
@@ -14732,7 +14732,7 @@
               </a:spcAft>
             </a:pPr>
             <a:r>
-              <a:rPr sz="1250" b="1">
+              <a:rPr sz="1200" b="1">
                 <a:solidFill>
                   <a:srgbClr val="123047"/>
                 </a:solidFill>
@@ -14823,13 +14823,13 @@
               </a:spcAft>
             </a:pPr>
             <a:r>
-              <a:rPr sz="1250" b="0">
+              <a:rPr sz="1200" b="0">
                 <a:solidFill>
                   <a:srgbClr val="1E2C33"/>
                 </a:solidFill>
                 <a:latin typeface="Segoe UI"/>
               </a:rPr>
-              <a:t>Cleaning, flag kalibrasi/serial</a:t>
+              <a:t>Membersihkan, menandai kalibrasi/serial</a:t>
             </a:r>
           </a:p>
         </p:txBody>
@@ -14914,13 +14914,13 @@
               </a:spcAft>
             </a:pPr>
             <a:r>
-              <a:rPr sz="1250" b="0">
+              <a:rPr sz="1200" b="0">
                 <a:solidFill>
                   <a:srgbClr val="1E2C33"/>
                 </a:solidFill>
                 <a:latin typeface="Segoe UI"/>
               </a:rPr>
-              <a:t>KPI turunan: AOV, MA, disc%</a:t>
+              <a:t>Menurunkan KPI: AOV, MA, disc%</a:t>
             </a:r>
           </a:p>
         </p:txBody>
@@ -15005,7 +15005,7 @@
               </a:spcAft>
             </a:pPr>
             <a:r>
-              <a:rPr sz="1250" b="1">
+              <a:rPr sz="1200" b="1">
                 <a:solidFill>
                   <a:srgbClr val="123047"/>
                 </a:solidFill>
@@ -15096,13 +15096,13 @@
               </a:spcAft>
             </a:pPr>
             <a:r>
-              <a:rPr sz="1250" b="0">
+              <a:rPr sz="1200" b="0">
                 <a:solidFill>
                   <a:srgbClr val="1E2C33"/>
                 </a:solidFill>
                 <a:latin typeface="Segoe UI"/>
               </a:rPr>
-              <a:t>Status, vendor, coverage kalibrasi</a:t>
+              <a:t>Status, vendor, cakupan kalibrasi</a:t>
             </a:r>
           </a:p>
         </p:txBody>
@@ -15187,7 +15187,7 @@
               </a:spcAft>
             </a:pPr>
             <a:r>
-              <a:rPr sz="1250" b="0">
+              <a:rPr sz="1200" b="0">
                 <a:solidFill>
                   <a:srgbClr val="1E2C33"/>
                 </a:solidFill>
@@ -15278,7 +15278,7 @@
               </a:spcAft>
             </a:pPr>
             <a:r>
-              <a:rPr sz="1250" b="1">
+              <a:rPr sz="1200" b="1">
                 <a:solidFill>
                   <a:srgbClr val="123047"/>
                 </a:solidFill>
@@ -15369,7 +15369,7 @@
               </a:spcAft>
             </a:pPr>
             <a:r>
-              <a:rPr sz="1250" b="0">
+              <a:rPr sz="1200" b="0">
                 <a:solidFill>
                   <a:srgbClr val="1E2C33"/>
                 </a:solidFill>
@@ -15460,7 +15460,7 @@
               </a:spcAft>
             </a:pPr>
             <a:r>
-              <a:rPr sz="1250" b="0">
+              <a:rPr sz="1200" b="0">
                 <a:solidFill>
                   <a:srgbClr val="1E2C33"/>
                 </a:solidFill>
@@ -15551,7 +15551,7 @@
               </a:spcAft>
             </a:pPr>
             <a:r>
-              <a:rPr sz="1250" b="1">
+              <a:rPr sz="1200" b="1">
                 <a:solidFill>
                   <a:srgbClr val="123047"/>
                 </a:solidFill>
@@ -15642,7 +15642,7 @@
               </a:spcAft>
             </a:pPr>
             <a:r>
-              <a:rPr sz="1250" b="0">
+              <a:rPr sz="1200" b="0">
                 <a:solidFill>
                   <a:srgbClr val="1E2C33"/>
                 </a:solidFill>
@@ -15733,7 +15733,7 @@
               </a:spcAft>
             </a:pPr>
             <a:r>
-              <a:rPr sz="1250" b="0">
+              <a:rPr sz="1200" b="0">
                 <a:solidFill>
                   <a:srgbClr val="1E2C33"/>
                 </a:solidFill>
@@ -15968,7 +15968,7 @@
                 </a:solidFill>
                 <a:latin typeface="Segoe UI Black"/>
               </a:rPr>
-              <a:t>BUSINESS QUESTIONS</a:t>
+              <a:t>PERTANYAAN BISNIS</a:t>
             </a:r>
           </a:p>
         </p:txBody>
@@ -16112,7 +16112,7 @@
                 </a:solidFill>
                 <a:latin typeface="Segoe UI"/>
               </a:rPr>
-              <a:t> memiliki sejumlah instrumen lapangan yang menopang keandalan, keselamatan, dan kepatuhan operasi. Data tersedia namun belum diolah dan kualitasnya belum dievaluasi.</a:t>
+              <a:t> mengoperasikan banyak instrumen lapangan yang menjadi tumpuan keandalan, keselamatan, dan kepatuhan operasi. Datanya sudah tersedia, tetapi belum diolah dan kualitasnya belum pernah dievaluasi.</a:t>
             </a:r>
           </a:p>
         </p:txBody>
@@ -16270,7 +16270,7 @@
                 </a:solidFill>
                 <a:latin typeface="Segoe UI"/>
               </a:rPr>
-              <a:t>Bagaimana sebaran instrumen aktif vs tidak aktif?</a:t>
+              <a:t>Bagaimana sebaran instrumen yang aktif dibanding yang tidak aktif?</a:t>
             </a:r>
           </a:p>
         </p:txBody>
@@ -16428,7 +16428,7 @@
                 </a:solidFill>
                 <a:latin typeface="Segoe UI"/>
               </a:rPr>
-              <a:t>Equipment class dan manufacturer apa yang dominan (ketergantungan vendor)?</a:t>
+              <a:t>Equipment class dan manufacturer apa yang paling dominan, dan seberapa besar ketergantungan vendornya?</a:t>
             </a:r>
           </a:p>
         </p:txBody>
@@ -16586,7 +16586,7 @@
                 </a:solidFill>
                 <a:latin typeface="Segoe UI"/>
               </a:rPr>
-              <a:t>Instrumen mana yang belum punya data kalibrasi (potensi gap keselamatan/kepatuhan)?</a:t>
+              <a:t>Instrumen mana yang belum memiliki data kalibrasi, sehingga berpotensi menimbulkan gap keselamatan dan kepatuhan?</a:t>
             </a:r>
           </a:p>
         </p:txBody>
@@ -16957,7 +16957,7 @@
                 </a:solidFill>
                 <a:latin typeface="Segoe UI"/>
               </a:rPr>
-              <a:t>Status: mayoritas instrumen Active (~94%), ketersediaan aset baik.</a:t>
+              <a:t>Mayoritas instrumen berstatus Active (~94%), menandakan ketersediaan aset yang baik.</a:t>
             </a:r>
           </a:p>
           <a:p>
@@ -16985,7 +16985,7 @@
                 </a:solidFill>
                 <a:latin typeface="Segoe UI"/>
               </a:rPr>
-              <a:t>Komposisi didominasi Actuator &amp; Pressure Transmitter; vendor terkonsentrasi pada Rosemount &amp; Honeywell → ada ketergantungan vendor.</a:t>
+              <a:t>Komposisi didominasi Actuator dan Pressure Transmitter, dengan vendor terpusat pada Rosemount dan Honeywell sehingga muncul ketergantungan vendor.</a:t>
             </a:r>
           </a:p>
           <a:p>
@@ -17013,7 +17013,7 @@
                 </a:solidFill>
                 <a:latin typeface="Segoe UI"/>
               </a:rPr>
-              <a:t>Insight utama: gap data kalibrasi signifikan; sebagian instrumen tidak memiliki Calibrate Range tercatat.</a:t>
+              <a:t>Temuan terpenting: cukup banyak instrumen belum memiliki Calibrate Range tercatat, menyisakan gap data kalibrasi yang signifikan.</a:t>
             </a:r>
           </a:p>
           <a:p>
@@ -17041,7 +17041,7 @@
                 </a:solidFill>
                 <a:latin typeface="Segoe UI"/>
               </a:rPr>
-              <a:t>Instrumen Active tanpa data kalibrasi menjadi watchlist prioritas (risiko kepatuhan/keselamatan).</a:t>
+              <a:t>Instrumen Active yang belum berkalibrasi masuk daftar prioritas karena berisiko terhadap kepatuhan dan keselamatan.</a:t>
             </a:r>
           </a:p>
           <a:p>
@@ -17069,7 +17069,7 @@
                 </a:solidFill>
                 <a:latin typeface="Segoe UI"/>
               </a:rPr>
-              <a:t>Sebagian Serial Number kosong → menyulitkan keterlacakan aset &amp; klaim garansi.</a:t>
+              <a:t>Sebagian Serial Number masih kosong, menyulitkan keterlacakan aset dan klaim garansi.</a:t>
             </a:r>
           </a:p>
         </p:txBody>
@@ -17213,7 +17213,7 @@
                 </a:solidFill>
                 <a:latin typeface="Segoe UI"/>
               </a:rPr>
-              <a:t>Lengkapi Calibrate Range &amp; Serial Number untuk instrumen prioritas (Active tanpa kalibrasi).</a:t>
+              <a:t>Lengkapi Calibrate Range dan Serial Number, dimulai dari instrumen prioritas yang aktif namun belum berkalibrasi.</a:t>
             </a:r>
           </a:p>
           <a:p>
@@ -17241,7 +17241,7 @@
                 </a:solidFill>
                 <a:latin typeface="Segoe UI"/>
               </a:rPr>
-              <a:t>Jadikan % cakupan kalibrasi sebagai KPI monitoring berkala di dashboard.</a:t>
+              <a:t>Jadikan persentase cakupan kalibrasi sebagai KPI yang dipantau berkala di dashboard.</a:t>
             </a:r>
           </a:p>
           <a:p>
@@ -17269,7 +17269,7 @@
                 </a:solidFill>
                 <a:latin typeface="Segoe UI"/>
               </a:rPr>
-              <a:t>Standardisasi input data di sumber untuk menghindari field kosong.</a:t>
+              <a:t>Standardkan pengisian data di sumbernya agar tidak ada field yang kosong.</a:t>
             </a:r>
           </a:p>
         </p:txBody>
@@ -17367,7 +17367,7 @@
                 </a:solidFill>
                 <a:latin typeface="Segoe UI"/>
               </a:rPr>
-              <a:t>sampel kecil (18 instrumen), satu area, snapshot satu waktu → analisis deskriptif, belum prediktif.</a:t>
+              <a:t>data masih terbatas (18 instrumen, satu area, satu titik waktu), sehingga analisis bersifat deskriptif dan belum prediktif.</a:t>
             </a:r>
           </a:p>
         </p:txBody>

</xml_diff>

<commit_message>
Fill cover with member names + dosen
</commit_message>
<xml_diff>
--- a/Final-Project-STI-Kel5-Presentation.pptx
+++ b/Final-Project-STI-Kel5-Presentation.pptx
@@ -3452,44 +3452,35 @@
               </a:spcAft>
             </a:pPr>
             <a:r>
-              <a:rPr sz="1400" b="1">
+              <a:rPr sz="1150" b="1">
                 <a:solidFill>
                   <a:srgbClr val="123047"/>
                 </a:solidFill>
                 <a:latin typeface="Segoe UI Semibold"/>
               </a:rPr>
-              <a:t>Moch Chesa Nur Hidayat</a:t>
-            </a:r>
-            <a:r>
-              <a:rPr sz="1300" b="0">
+              <a:t>Moch Chesa Nur Hidayat  ·  Misbahul Munir Dwi Julianto  ·  Eko Yunianto</a:t>
+            </a:r>
+          </a:p>
+          <a:p>
+            <a:pPr algn="l">
+              <a:lnSpc>
+                <a:spcPct val="110000"/>
+              </a:lnSpc>
+              <a:spcBef>
+                <a:spcPts val="0"/>
+              </a:spcBef>
+              <a:spcAft>
+                <a:spcPts val="300"/>
+              </a:spcAft>
+            </a:pPr>
+            <a:r>
+              <a:rPr sz="1000" b="0">
                 <a:solidFill>
                   <a:srgbClr val="8A98A0"/>
                 </a:solidFill>
                 <a:latin typeface="Segoe UI"/>
               </a:rPr>
-              <a:t>    ·    [Anggota 2]    ·    [Anggota 3]</a:t>
-            </a:r>
-          </a:p>
-          <a:p>
-            <a:pPr algn="l">
-              <a:lnSpc>
-                <a:spcPct val="110000"/>
-              </a:lnSpc>
-              <a:spcBef>
-                <a:spcPts val="0"/>
-              </a:spcBef>
-              <a:spcAft>
-                <a:spcPts val="300"/>
-              </a:spcAft>
-            </a:pPr>
-            <a:r>
-              <a:rPr sz="1000" b="0">
-                <a:solidFill>
-                  <a:srgbClr val="8A98A0"/>
-                </a:solidFill>
-                <a:latin typeface="Segoe UI"/>
-              </a:rPr>
-              <a:t>GitHub: sianida26, Misbahulmunir26, …     |     Dosen: [isi nama dosen]</a:t>
+              <a:t>Dosen Pengampu: Dr. Agus Budi Raharjo     |     GitHub: sianida26, Misbahulmunir26</a:t>
             </a:r>
           </a:p>
         </p:txBody>

</xml_diff>